<commit_message>
Milestone 4 write-up and slides: sign-in on the team's own Firebase project, image v4
</commit_message>
<xml_diff>
--- a/docs/deploy/Milestone4_State.pptx
+++ b/docs/deploy/Milestone4_State.pptx
@@ -108,12 +108,12 @@
   <p:extLst>
     <p:ext uri="{521415D9-36F7-43E2-AB2F-B90AF26B5E84}">
       <p14:sectionLst xmlns:p14="http://schemas.microsoft.com/office/powerpoint/2010/main">
-        <p14:section name="Architecture" id="{dd644e8f-8761-5261-cf15-7a689833c69d}">
+        <p14:section name="Architecture" id="{a351480e-23d1-bcaf-4b26-baf6c37b4a74}">
           <p14:sldIdLst>
             <p14:sldId id="256"/>
           </p14:sldIdLst>
         </p14:section>
-        <p14:section name="Identity and network" id="{0d67e42c-1183-0b75-614a-885ba06c4706}">
+        <p14:section name="Identity and network" id="{270699de-e0e4-08c3-e3af-6cbb21d70ff8}">
           <p14:sldIdLst>
             <p14:sldId id="257"/>
           </p14:sldIdLst>
@@ -2245,7 +2245,7 @@
                   <a:schemeClr val="tx2"/>
                 </a:solidFill>
               </a:rPr>
-              <a:t>app:v3 image</a:t>
+              <a:t>app:v4 image</a:t>
             </a:r>
             <a:endParaRPr lang="en-US" sz="1300" dirty="0"/>
           </a:p>
@@ -2889,11 +2889,11 @@
         <p:spPr>
           <a:xfrm>
             <a:off x="2926080" y="1600200"/>
-            <a:ext cx="4983480" cy="1234440"/>
+            <a:ext cx="4983480" cy="1463040"/>
           </a:xfrm>
           <a:prstGeom prst="roundRect">
             <a:avLst>
-              <a:gd name="adj" fmla="val 5926"/>
+              <a:gd name="adj" fmla="val 5000"/>
             </a:avLst>
           </a:prstGeom>
           <a:solidFill>
@@ -2916,7 +2916,7 @@
         <p:spPr>
           <a:xfrm>
             <a:off x="3017520" y="1664208"/>
-            <a:ext cx="4800600" cy="1143000"/>
+            <a:ext cx="4800600" cy="1371600"/>
           </a:xfrm>
           <a:prstGeom prst="rect">
             <a:avLst/>
@@ -2983,6 +2983,20 @@
             </a:r>
             <a:endParaRPr lang="en-US" sz="1300" dirty="0"/>
           </a:p>
+          <a:p>
+            <a:pPr algn="l" indent="0" marL="0">
+              <a:buNone/>
+            </a:pPr>
+            <a:r>
+              <a:rPr lang="en-US" sz="1100" dirty="0">
+                <a:solidFill>
+                  <a:schemeClr val="tx2"/>
+                </a:solidFill>
+              </a:rPr>
+              <a:t>Google sign-in: Firebase project mahokshahvata, public keys only</a:t>
+            </a:r>
+            <a:endParaRPr lang="en-US" sz="1300" dirty="0"/>
+          </a:p>
         </p:txBody>
       </p:sp>
       <p:sp>
@@ -2993,8 +3007,8 @@
         </p:nvSpPr>
         <p:spPr>
           <a:xfrm>
-            <a:off x="5394960" y="2834640"/>
-            <a:ext cx="914" cy="594360"/>
+            <a:off x="5394960" y="3063240"/>
+            <a:ext cx="914" cy="365760"/>
           </a:xfrm>
           <a:prstGeom prst="line">
             <a:avLst/>
@@ -3017,7 +3031,7 @@
         </p:nvSpPr>
         <p:spPr>
           <a:xfrm>
-            <a:off x="5486400" y="2999232"/>
+            <a:off x="5486400" y="3127248"/>
             <a:ext cx="2194560" cy="274320"/>
           </a:xfrm>
           <a:prstGeom prst="rect">

</xml_diff>